<commit_message>
Meta earnings update: after-hours reaction and a dedicated Muse paragraph
Co-Authored-By: Claude Opus 5.5 <noreply@anthropic.com>
Claude-Session: https://claude.ai/code/session_01N4CkkntnhRz2pC9J6acWNT
</commit_message>
<xml_diff>
--- a/notes/2026-10-21-meta-q3-results/syz-earnings/out/Earnings_Update_META_Q32026.pptx
+++ b/notes/2026-10-21-meta-q3-results/syz-earnings/out/Earnings_Update_META_Q32026.pptx
@@ -2647,7 +2647,7 @@
                 <a:ea typeface="Nunito" pitchFamily="34" charset="-122"/>
                 <a:cs typeface="Nunito" pitchFamily="34" charset="-120"/>
               </a:rPr>
-              <a:t>We stay constructive on Meta over the long term. The share is on the Syz master list but not on the focus list, and this update is not a recommendation to buy it. The earnings path we underwrite rests on advertising: management expects to sustain strong revenue growth throughout 2027 and Reality Labs losses to narrow to about USD 15bn. The debate has moved from whether AI pays in advertising to what the AI build-out costs. Expectations were high into the print after a 19% rise since the July results. The next test is the 2027 capex and expense guidance with the Q4 results in late January.</a:t>
+              <a:t>We stay constructive on Meta over the long term. The share is on the Syz master list but not on the focus list, and this update is not a recommendation to buy it. We underwrite an advertising-led earnings path: management expects strong revenue growth throughout 2027 and Reality Labs losses to narrow to about USD 15bn. The debate is now the cost of the AI build-out, as the reaction showed: after a 19% rise since July, the share spiked by about 7% after hours, then gave back most of the gain once management said Muse’s serving costs would rise. The next test is the 2027 guidance in late January.</a:t>
             </a:r>
             <a:endParaRPr lang="en-US" sz="870" dirty="0"/>
           </a:p>
@@ -3083,7 +3083,7 @@
         <p:spPr>
           <a:xfrm>
             <a:off x="539496" y="1431036"/>
-            <a:ext cx="6483096" cy="959663"/>
+            <a:ext cx="6483096" cy="802767"/>
           </a:xfrm>
           <a:prstGeom prst="rect">
             <a:avLst/>
@@ -3110,7 +3110,7 @@
                 <a:ea typeface="Nunito" pitchFamily="34" charset="-122"/>
                 <a:cs typeface="Nunito" pitchFamily="34" charset="-120"/>
               </a:rPr>
-              <a:t>Family of Apps revenue reached USD 64.2bn, up 26%, with advertising at USD 63.1bn, also up 26% at constant currency. Ad impressions grew 10%, driven by engagement, users and ad load, and the average price per ad rose 14% on better ad performance and an easier macro backdrop, partly offset by faster impression growth in lower-monetising regions. Daily active people reached 3.64bn. Other Family of Apps revenue grew 59% to USD 1.1bn on WhatsApp paid messaging and subscriptions, and Meta One, the new subscription bundle, passed 15 million subscriptions and trials. Reality Labs revenue fell 6% to USD 443m as lower Quest sales offset growth in AI glasses.</a:t>
+              <a:t>Family of Apps revenue reached USD 64.2bn, up 26%, with advertising at USD 63.1bn, also up 26% at constant currency. Ad impressions grew 10%, and the average price per ad rose 14% on better ad performance and an easier macro backdrop. Daily active people reached 3.64bn. Other Family of Apps revenue grew 59% to USD 1.1bn on WhatsApp paid messaging and subscriptions, and Meta One, the new subscription bundle, passed 15 million subscriptions and trials. Reality Labs revenue fell 6% to USD 443m as lower Quest sales offset growth in AI glasses.</a:t>
             </a:r>
             <a:endParaRPr lang="en-US" sz="870" dirty="0"/>
           </a:p>
@@ -3124,7 +3124,7 @@
         </p:nvSpPr>
         <p:spPr>
           <a:xfrm>
-            <a:off x="539496" y="2470252"/>
+            <a:off x="539496" y="2313356"/>
             <a:ext cx="6483096" cy="802767"/>
           </a:xfrm>
           <a:prstGeom prst="rect">
@@ -3152,7 +3152,7 @@
                 <a:ea typeface="Nunito" pitchFamily="34" charset="-122"/>
                 <a:cs typeface="Nunito" pitchFamily="34" charset="-120"/>
               </a:rPr>
-              <a:t>Total expenses rose 68% to USD 51.6bn, including the USD 9.9bn charge for the August settlement with US state attorneys general; the rest of the increase came from infrastructure, depreciation and third-party AI token costs. Headcount fell 12% from Q2 to about 66,000. Reported operating income dropped 37% to USD 13.0bn, a 20% margin; excluding the charge it rose 11% to USD 22.9bn, a margin of about 35% against 40% a year ago. Capex of USD 34.9bn left free cash flow negative at USD 2.1bn, and debt of USD 83.7bn now slightly exceeds cash and marketable securities of USD 82.4bn.</a:t>
+              <a:t>Total expenses rose 68% to USD 51.6bn, including the USD 9.9bn charge for the August settlement with US state attorneys general; the rest came from infrastructure and third-party AI token costs. Headcount fell 12% from Q2 to about 66,000. Reported operating income dropped 37% to USD 13.0bn, a 20% margin; excluding the charge it rose 11% to USD 22.9bn, a margin of about 35% against 40% a year ago. Capex of USD 34.9bn left free cash flow negative at USD 2.1bn, and debt of USD 83.7bn now slightly exceeds cash and marketable securities of USD 82.4bn.</a:t>
             </a:r>
             <a:endParaRPr lang="en-US" sz="870" dirty="0"/>
           </a:p>
@@ -3166,7 +3166,7 @@
         </p:nvSpPr>
         <p:spPr>
           <a:xfrm>
-            <a:off x="539496" y="3389147"/>
+            <a:off x="539496" y="3232252"/>
             <a:ext cx="6483096" cy="219456"/>
           </a:xfrm>
           <a:prstGeom prst="rect">
@@ -3191,7 +3191,7 @@
                 <a:ea typeface="Nunito" pitchFamily="34" charset="-122"/>
                 <a:cs typeface="Nunito" pitchFamily="34" charset="-120"/>
               </a:rPr>
-              <a:t>Outlook: 2026 holds, 2027 waits for January</a:t>
+              <a:t>Outlook: 2027 waits for January, Muse for scale</a:t>
             </a:r>
             <a:endParaRPr lang="en-US" sz="1100" dirty="0"/>
           </a:p>
@@ -3205,8 +3205,8 @@
         </p:nvSpPr>
         <p:spPr>
           <a:xfrm>
-            <a:off x="539496" y="3636035"/>
-            <a:ext cx="6483096" cy="959663"/>
+            <a:off x="539496" y="3479140"/>
+            <a:ext cx="6483096" cy="645871"/>
           </a:xfrm>
           <a:prstGeom prst="rect">
             <a:avLst/>
@@ -3233,7 +3233,7 @@
                 <a:ea typeface="Nunito" pitchFamily="34" charset="-122"/>
                 <a:cs typeface="Nunito" pitchFamily="34" charset="-120"/>
               </a:rPr>
-              <a:t>The Q4 revenue guide of USD 73–76bn, including a 1% currency headwind, compares with FactSet consensus of USD 73.65bn. Full-year 2026 expenses of USD 175–179bn are the previous range plus the legal charge, and the 2026 capex range was narrowed to USD 135–145bn. For 2027, management is still building its budget, expects to keep investing aggressively and gives no figure before the Q4 call. Muse is compute-intensive: serving costs will rise, but Meta aims for a more than tenfold efficiency gain next year and plans to monetise sooner. A new non-voting share, distributed one for one from late January, widens funding options; no financing is planned.</a:t>
+              <a:t>The Q4 revenue guide of USD 73–76bn compares with FactSet consensus of USD 73.65bn. Full-year 2026 expenses of USD 175–179bn are the previous range plus the legal charge, and the 2026 capex range was narrowed to USD 135–145bn. For 2027, management expects to keep investing aggressively but gives no figure before the Q4 call. A new non-voting share, distributed one for one from late January, widens funding options; no financing is planned.</a:t>
             </a:r>
             <a:endParaRPr lang="en-US" sz="870" dirty="0"/>
           </a:p>
@@ -3247,7 +3247,49 @@
         </p:nvSpPr>
         <p:spPr>
           <a:xfrm>
-            <a:off x="539496" y="4711827"/>
+            <a:off x="539496" y="4204564"/>
+            <a:ext cx="6483096" cy="959663"/>
+          </a:xfrm>
+          <a:prstGeom prst="rect">
+            <a:avLst/>
+          </a:prstGeom>
+          <a:noFill/>
+          <a:ln/>
+        </p:spPr>
+        <p:txBody>
+          <a:bodyPr wrap="square" lIns="0" tIns="0" rIns="0" bIns="0" rtlCol="0" anchor="t"/>
+          <a:lstStyle/>
+          <a:p>
+            <a:pPr algn="just" indent="0" marL="0">
+              <a:lnSpc>
+                <a:spcPct val="118333"/>
+              </a:lnSpc>
+              <a:buNone/>
+            </a:pPr>
+            <a:r>
+              <a:rPr lang="en-US" sz="870" b="1" dirty="0">
+                <a:solidFill>
+                  <a:srgbClr val="202945"/>
+                </a:solidFill>
+                <a:latin typeface="Nunito" pitchFamily="34" charset="0"/>
+                <a:ea typeface="Nunito" pitchFamily="34" charset="-122"/>
+                <a:cs typeface="Nunito" pitchFamily="34" charset="-120"/>
+              </a:rPr>
+              <a:t>Muse is where the 2027 bill and the upside meet. Over a quarter of weekly users shop through it, with an average purchase above USD 200, and Muse Wonder, in the paid tier, lifts retention. Most users would stay free, with businesses paying a fee on transactions, while subscriptions cover advanced models and business use. Its US users already bring several hundred dollars a year each in app revenue, and Meta expects Muse to reach a higher level through commerce. Serving costs will rise as capacity is built for over 1 billion users; Meta targets a more than tenfold efficiency gain next year but gives no cost per user.</a:t>
+            </a:r>
+            <a:endParaRPr lang="en-US" sz="870" dirty="0"/>
+          </a:p>
+        </p:txBody>
+      </p:sp>
+      <p:sp>
+        <p:nvSpPr>
+          <p:cNvPr id="13" name="Text 9"/>
+          <p:cNvSpPr txBox="1"/>
+          <p:nvPr/>
+        </p:nvSpPr>
+        <p:spPr>
+          <a:xfrm>
+            <a:off x="539496" y="5280355"/>
             <a:ext cx="6483096" cy="219456"/>
           </a:xfrm>
           <a:prstGeom prst="rect">
@@ -3280,13 +3322,13 @@
       </p:sp>
       <p:sp>
         <p:nvSpPr>
-          <p:cNvPr id="13" name="Text 9"/>
-          <p:cNvSpPr txBox="1"/>
-          <p:nvPr/>
-        </p:nvSpPr>
-        <p:spPr>
-          <a:xfrm>
-            <a:off x="539496" y="4958715"/>
+          <p:cNvPr id="14" name="Text 10"/>
+          <p:cNvSpPr txBox="1"/>
+          <p:nvPr/>
+        </p:nvSpPr>
+        <p:spPr>
+          <a:xfrm>
+            <a:off x="539496" y="5527243"/>
             <a:ext cx="6483096" cy="182880"/>
           </a:xfrm>
           <a:prstGeom prst="rect">
@@ -3333,13 +3375,13 @@
       </p:sp>
       <p:sp>
         <p:nvSpPr>
-          <p:cNvPr id="14" name="Text 10"/>
-          <p:cNvSpPr txBox="1"/>
-          <p:nvPr/>
-        </p:nvSpPr>
-        <p:spPr>
-          <a:xfrm>
-            <a:off x="539496" y="5141595"/>
+          <p:cNvPr id="15" name="Text 11"/>
+          <p:cNvSpPr txBox="1"/>
+          <p:nvPr/>
+        </p:nvSpPr>
+        <p:spPr>
+          <a:xfrm>
+            <a:off x="539496" y="5710123"/>
             <a:ext cx="6483096" cy="237744"/>
           </a:xfrm>
           <a:prstGeom prst="rect">
@@ -3375,7 +3417,7 @@
       </p:sp>
       <p:pic>
         <p:nvPicPr>
-          <p:cNvPr id="15" name="Image 2" descr="/home/user/adhoc_Equity/notes/2026-10-21-meta-q3-results/syz-earnings/out/c2_crop.png">    </p:cNvPr>
+          <p:cNvPr id="16" name="Image 2" descr="/home/user/adhoc_Equity/notes/2026-10-21-meta-q3-results/syz-earnings/out/c2_crop.png">    </p:cNvPr>
           <p:cNvPicPr>
             <a:picLocks noChangeAspect="1"/>
           </p:cNvPicPr>
@@ -3389,8 +3431,8 @@
         </p:blipFill>
         <p:spPr>
           <a:xfrm>
-            <a:off x="928482" y="5425059"/>
-            <a:ext cx="5705124" cy="3413946"/>
+            <a:off x="1187806" y="5993587"/>
+            <a:ext cx="5186477" cy="3103588"/>
           </a:xfrm>
           <a:prstGeom prst="rect">
             <a:avLst/>
@@ -3399,14 +3441,14 @@
       </p:pic>
       <p:sp>
         <p:nvSpPr>
-          <p:cNvPr id="16" name="Text 11"/>
-          <p:cNvSpPr txBox="1"/>
-          <p:nvPr/>
-        </p:nvSpPr>
-        <p:spPr>
-          <a:xfrm>
-            <a:off x="539496" y="8893869"/>
-            <a:ext cx="6483096" cy="802767"/>
+          <p:cNvPr id="17" name="Text 12"/>
+          <p:cNvSpPr txBox="1"/>
+          <p:nvPr/>
+        </p:nvSpPr>
+        <p:spPr>
+          <a:xfrm>
+            <a:off x="539496" y="9152039"/>
+            <a:ext cx="6483096" cy="645871"/>
           </a:xfrm>
           <a:prstGeom prst="rect">
             <a:avLst/>
@@ -3433,7 +3475,7 @@
                 <a:ea typeface="Nunito" pitchFamily="34" charset="-122"/>
                 <a:cs typeface="Nunito" pitchFamily="34" charset="-120"/>
               </a:rPr>
-              <a:t>At USD 697.5, the share is 2.7% lower than a year ago while 12-month forward consensus earnings fell 5.3%. Since the July results the gap is wider: the price is up 19.1% and forward earnings are down 10.4%, taking the multiple from 16.1x to 21.3x. That is 4.8% below the 22.4x average since 2016, but above the one-year average of 19.2x and well above the 14.9x low of June 2026. The share trades 10% above its 40-week average. A 10% earnings upgrade at an unchanged price would bring the multiple back to 19.4x, its one-year average.</a:t>
+              <a:t>At USD 697.5, 10% above its 40-week average, the share is 2.7% lower than a year ago while forward consensus earnings fell 5.3%. Since July the gap is wider: the price is up 19.1% and forward earnings are down 10.4%, taking the multiple from 16.1x to 21.3x. That is 4.8% below the 22.4x average since 2016, but above the one-year average of 19.2x and the 14.9x low of June 2026. A 10% earnings upgrade at an unchanged price would bring the multiple back to 19.4x, its one-year average.</a:t>
             </a:r>
             <a:endParaRPr lang="en-US" sz="870" dirty="0"/>
           </a:p>

</xml_diff>

<commit_message>
Meta earnings update: flag the legal charge's distortion of reported EPS on page 1
Co-Authored-By: Claude Opus 5.5 <noreply@anthropic.com>
Claude-Session: https://claude.ai/code/session_01N4CkkntnhRz2pC9J6acWNT
</commit_message>
<xml_diff>
--- a/notes/2026-10-21-meta-q3-results/syz-earnings/out/Earnings_Update_META_Q32026.pptx
+++ b/notes/2026-10-21-meta-q3-results/syz-earnings/out/Earnings_Update_META_Q32026.pptx
@@ -1519,7 +1519,7 @@
                 <a:ea typeface="Nunito" pitchFamily="34" charset="-122"/>
                 <a:cs typeface="Nunito" pitchFamily="34" charset="-120"/>
               </a:rPr>
-              <a:t>Revenue USD 64.6bn, 2% above consensus and the top of guidance, on a 14% higher price per ad.</a:t>
+              <a:t>Revenue +2% vs. consensus; EPS of USD 7.40 (+13%) excludes a USD 9.9bn legal charge, reported USD 3.83.</a:t>
             </a:r>
             <a:endParaRPr lang="en-US" sz="870" dirty="0"/>
           </a:p>
@@ -2044,7 +2044,7 @@
                 <a:ea typeface="Nunito" pitchFamily="34" charset="-122"/>
                 <a:cs typeface="Nunito" pitchFamily="34" charset="-120"/>
               </a:rPr>
-              <a:t>+13.1% vs. consensus</a:t>
+              <a:t>+13.1% vs. cons.; reported 3.83</a:t>
             </a:r>
             <a:endParaRPr lang="en-US" sz="720" dirty="0"/>
           </a:p>
@@ -2405,7 +2405,7 @@
                 <a:ea typeface="Nunito" pitchFamily="34" charset="-122"/>
                 <a:cs typeface="Nunito" pitchFamily="34" charset="-120"/>
               </a:rPr>
-              <a:t>The quarter answered two of the three questions we set before the print. Advertising delivered, with operating income 13% above consensus once the USD 9.9bn legal charge is excluded, and Muse, Meta’s new personal AI agent, came with usage data rather than downloads alone. The third question, the size of the 2027 investment bill, is deferred to the Q4 results in January, while free cash flow turned negative this quarter.</a:t>
+              <a:t>The quarter answered two of the three questions we set before the print: advertising delivered, and Muse, Meta’s new personal AI agent, came with usage data rather than downloads alone. Reported earnings, however, need careful reading: the legal settlement charge, partly non-deductible, halves reported EPS, so the headline figure is not an operating miss. The third question, the 2027 investment bill, is deferred to January, while free cash flow turned negative.</a:t>
             </a:r>
             <a:endParaRPr lang="en-US" sz="870" dirty="0"/>
           </a:p>

</xml_diff>